<commit_message>
Update README, results, and executive readout
</commit_message>
<xml_diff>
--- a/presentation/Executive_Readout.pptx
+++ b/presentation/Executive_Readout.pptx
@@ -4,6 +4,9 @@
   <p:sldMasterIdLst>
     <p:sldMasterId id="2147483648" r:id="rId1"/>
   </p:sldMasterIdLst>
+  <p:notesMasterIdLst>
+    <p:notesMasterId r:id="rId10"/>
+  </p:notesMasterIdLst>
   <p:sldIdLst>
     <p:sldId id="256" r:id="rId2"/>
     <p:sldId id="257" r:id="rId3"/>
@@ -14,9 +17,6 @@
     <p:sldId id="262" r:id="rId8"/>
     <p:sldId id="263" r:id="rId9"/>
   </p:sldIdLst>
-  <p:notesMasterIdLst>
-    <p:notesMasterId r:id="rId10"/>
-  </p:notesMasterIdLst>
   <p:sldSz cx="12192000" cy="6858000"/>
   <p:notesSz cx="6858000" cy="12192000"/>
   <p:defaultTextStyle>
@@ -111,6 +111,11 @@
       </a:defRPr>
     </a:lvl9pPr>
   </p:defaultTextStyle>
+  <p:extLst>
+    <p:ext uri="{EFAFB233-063F-42B5-8137-9DF3F51BA10A}">
+      <p15:sldGuideLst xmlns:p15="http://schemas.microsoft.com/office/powerpoint/2012/main"/>
+    </p:ext>
+  </p:extLst>
 </p:presentation>
 </file>
 
@@ -136,234 +141,10 @@
           <a:chExt cx="0" cy="0"/>
         </a:xfrm>
       </p:grpSpPr>
-      <p:sp>
-        <p:nvSpPr>
-          <p:cNvPr id="2" name="Header Placeholder 1"/>
-          <p:cNvSpPr>
-            <a:spLocks noGrp="1"/>
-          </p:cNvSpPr>
-          <p:nvPr>
-            <p:ph type="hdr" sz="quarter"/>
-          </p:nvPr>
-        </p:nvSpPr>
-        <p:spPr>
-          <a:xfrm>
-            <a:off x="0" y="0"/>
-            <a:ext cx="2971800" cy="458788"/>
-          </a:xfrm>
-          <a:prstGeom prst="rect">
-            <a:avLst/>
-          </a:prstGeom>
-        </p:spPr>
-        <p:txBody>
-          <a:bodyPr vert="horz" lIns="91440" tIns="45720" rIns="91440" bIns="45720" rtlCol="0"/>
-          <a:lstStyle>
-            <a:lvl1pPr algn="l">
-              <a:defRPr sz="1200"/>
-            </a:lvl1pPr>
-          </a:lstStyle>
-          <a:p>
-            <a:endParaRPr lang="en-US"/>
-          </a:p>
-        </p:txBody>
-      </p:sp>
-      <p:sp>
-        <p:nvSpPr>
-          <p:cNvPr id="3" name="Date Placeholder 2"/>
-          <p:cNvSpPr>
-            <a:spLocks noGrp="1"/>
-          </p:cNvSpPr>
-          <p:nvPr>
-            <p:ph type="dt" idx="1"/>
-          </p:nvPr>
-        </p:nvSpPr>
-        <p:spPr>
-          <a:xfrm>
-            <a:off x="3884613" y="0"/>
-            <a:ext cx="2971800" cy="458788"/>
-          </a:xfrm>
-          <a:prstGeom prst="rect">
-            <a:avLst/>
-          </a:prstGeom>
-        </p:spPr>
-        <p:txBody>
-          <a:bodyPr vert="horz" lIns="91440" tIns="45720" rIns="91440" bIns="45720" rtlCol="0"/>
-          <a:lstStyle>
-            <a:lvl1pPr algn="r">
-              <a:defRPr sz="1200"/>
-            </a:lvl1pPr>
-          </a:lstStyle>
-          <a:p>
-            <a:fld id="{5282F153-3F37-0F45-9E97-73ACFA13230C}" type="datetimeFigureOut">
-              <a:rPr lang="en-US"/>
-              <a:t>7/23/19</a:t>
-            </a:fld>
-            <a:endParaRPr lang="en-US"/>
-          </a:p>
-        </p:txBody>
-      </p:sp>
-      <p:sp>
-        <p:nvSpPr>
-          <p:cNvPr id="4" name="Slide Image Placeholder 3"/>
-          <p:cNvSpPr>
-            <a:spLocks noGrp="1" noRot="1" noChangeAspect="1"/>
-          </p:cNvSpPr>
-          <p:nvPr>
-            <p:ph type="sldImg" idx="2"/>
-          </p:nvPr>
-        </p:nvSpPr>
-        <p:spPr>
-          <a:xfrm>
-            <a:off x="685800" y="1143000"/>
-            <a:ext cx="5486400" cy="3086100"/>
-          </a:xfrm>
-          <a:prstGeom prst="rect">
-            <a:avLst/>
-          </a:prstGeom>
-          <a:noFill/>
-          <a:ln w="12700">
-            <a:solidFill>
-              <a:prstClr val="black"/>
-            </a:solidFill>
-          </a:ln>
-        </p:spPr>
-        <p:txBody>
-          <a:bodyPr vert="horz" lIns="91440" tIns="45720" rIns="91440" bIns="45720" rtlCol="0" anchor="ctr"/>
-          <a:lstStyle/>
-          <a:p>
-            <a:endParaRPr lang="en-US"/>
-          </a:p>
-        </p:txBody>
-      </p:sp>
-      <p:sp>
-        <p:nvSpPr>
-          <p:cNvPr id="5" name="Notes Placeholder 4"/>
-          <p:cNvSpPr>
-            <a:spLocks noGrp="1"/>
-          </p:cNvSpPr>
-          <p:nvPr>
-            <p:ph type="body" sz="quarter" idx="3"/>
-          </p:nvPr>
-        </p:nvSpPr>
-        <p:spPr>
-          <a:xfrm>
-            <a:off x="685800" y="4400550"/>
-            <a:ext cx="5486400" cy="3600450"/>
-          </a:xfrm>
-          <a:prstGeom prst="rect">
-            <a:avLst/>
-          </a:prstGeom>
-        </p:spPr>
-        <p:txBody>
-          <a:bodyPr vert="horz" lIns="91440" tIns="45720" rIns="91440" bIns="45720" rtlCol="0"/>
-          <a:lstStyle/>
-          <a:p>
-            <a:pPr lvl="0"/>
-            <a:r>
-              <a:rPr lang="en-US"/>
-              <a:t>Click to edit Master text styles</a:t>
-            </a:r>
-          </a:p>
-          <a:p>
-            <a:pPr lvl="1"/>
-            <a:r>
-              <a:rPr lang="en-US"/>
-              <a:t>Second level</a:t>
-            </a:r>
-          </a:p>
-          <a:p>
-            <a:pPr lvl="2"/>
-            <a:r>
-              <a:rPr lang="en-US"/>
-              <a:t>Third level</a:t>
-            </a:r>
-          </a:p>
-          <a:p>
-            <a:pPr lvl="3"/>
-            <a:r>
-              <a:rPr lang="en-US"/>
-              <a:t>Fourth level</a:t>
-            </a:r>
-          </a:p>
-          <a:p>
-            <a:pPr lvl="4"/>
-            <a:r>
-              <a:rPr lang="en-US"/>
-              <a:t>Fifth level</a:t>
-            </a:r>
-          </a:p>
-        </p:txBody>
-      </p:sp>
-      <p:sp>
-        <p:nvSpPr>
-          <p:cNvPr id="6" name="Footer Placeholder 5"/>
-          <p:cNvSpPr>
-            <a:spLocks noGrp="1"/>
-          </p:cNvSpPr>
-          <p:nvPr>
-            <p:ph type="ftr" sz="quarter" idx="4"/>
-          </p:nvPr>
-        </p:nvSpPr>
-        <p:spPr>
-          <a:xfrm>
-            <a:off x="0" y="8685213"/>
-            <a:ext cx="2971800" cy="458787"/>
-          </a:xfrm>
-          <a:prstGeom prst="rect">
-            <a:avLst/>
-          </a:prstGeom>
-        </p:spPr>
-        <p:txBody>
-          <a:bodyPr vert="horz" lIns="91440" tIns="45720" rIns="91440" bIns="45720" rtlCol="0" anchor="b"/>
-          <a:lstStyle>
-            <a:lvl1pPr algn="l">
-              <a:defRPr sz="1200"/>
-            </a:lvl1pPr>
-          </a:lstStyle>
-          <a:p>
-            <a:endParaRPr lang="en-US"/>
-          </a:p>
-        </p:txBody>
-      </p:sp>
-      <p:sp>
-        <p:nvSpPr>
-          <p:cNvPr id="7" name="Slide Number Placeholder 6"/>
-          <p:cNvSpPr>
-            <a:spLocks noGrp="1"/>
-          </p:cNvSpPr>
-          <p:nvPr>
-            <p:ph type="sldNum" sz="quarter" idx="5"/>
-          </p:nvPr>
-        </p:nvSpPr>
-        <p:spPr>
-          <a:xfrm>
-            <a:off x="3884613" y="8685213"/>
-            <a:ext cx="2971800" cy="458787"/>
-          </a:xfrm>
-          <a:prstGeom prst="rect">
-            <a:avLst/>
-          </a:prstGeom>
-        </p:spPr>
-        <p:txBody>
-          <a:bodyPr vert="horz" lIns="91440" tIns="45720" rIns="91440" bIns="45720" rtlCol="0" anchor="b"/>
-          <a:lstStyle>
-            <a:lvl1pPr algn="r">
-              <a:defRPr sz="1200"/>
-            </a:lvl1pPr>
-          </a:lstStyle>
-          <a:p>
-            <a:fld id="{CE5E9CC1-C706-0F49-92D6-E571CC5EEA8F}" type="slidenum">
-              <a:rPr lang="en-US"/>
-              <a:t>‹#›</a:t>
-            </a:fld>
-            <a:endParaRPr lang="en-US"/>
-          </a:p>
-        </p:txBody>
-      </p:sp>
     </p:spTree>
     <p:extLst>
       <p:ext uri="{BB962C8B-B14F-4D97-AF65-F5344CB8AC3E}">
-        <p14:creationId xmlns:p14="http://schemas.microsoft.com/office/powerpoint/2010/main" val="1024086991"/>
+        <p14:creationId xmlns:p14="http://schemas.microsoft.com/office/powerpoint/2010/main" val="2484791945"/>
       </p:ext>
     </p:extLst>
   </p:cSld>
@@ -507,10 +288,6 @@
           <a:bodyPr/>
           <a:lstStyle/>
           <a:p>
-            <a:r>
-              <a:rPr lang="en-US" dirty="0"/>
-              <a:t/>
-            </a:r>
             <a:endParaRPr lang="en-US" dirty="0"/>
           </a:p>
         </p:txBody>
@@ -595,10 +372,6 @@
           <a:bodyPr/>
           <a:lstStyle/>
           <a:p>
-            <a:r>
-              <a:rPr lang="en-US" dirty="0"/>
-              <a:t/>
-            </a:r>
             <a:endParaRPr lang="en-US" dirty="0"/>
           </a:p>
         </p:txBody>
@@ -683,10 +456,6 @@
           <a:bodyPr/>
           <a:lstStyle/>
           <a:p>
-            <a:r>
-              <a:rPr lang="en-US" dirty="0"/>
-              <a:t/>
-            </a:r>
             <a:endParaRPr lang="en-US" dirty="0"/>
           </a:p>
         </p:txBody>
@@ -771,10 +540,6 @@
           <a:bodyPr/>
           <a:lstStyle/>
           <a:p>
-            <a:r>
-              <a:rPr lang="en-US" dirty="0"/>
-              <a:t/>
-            </a:r>
             <a:endParaRPr lang="en-US" dirty="0"/>
           </a:p>
         </p:txBody>
@@ -859,10 +624,6 @@
           <a:bodyPr/>
           <a:lstStyle/>
           <a:p>
-            <a:r>
-              <a:rPr lang="en-US" dirty="0"/>
-              <a:t/>
-            </a:r>
             <a:endParaRPr lang="en-US" dirty="0"/>
           </a:p>
         </p:txBody>
@@ -947,10 +708,6 @@
           <a:bodyPr/>
           <a:lstStyle/>
           <a:p>
-            <a:r>
-              <a:rPr lang="en-US" dirty="0"/>
-              <a:t/>
-            </a:r>
             <a:endParaRPr lang="en-US" dirty="0"/>
           </a:p>
         </p:txBody>
@@ -1035,10 +792,6 @@
           <a:bodyPr/>
           <a:lstStyle/>
           <a:p>
-            <a:r>
-              <a:rPr lang="en-US" dirty="0"/>
-              <a:t/>
-            </a:r>
             <a:endParaRPr lang="en-US" dirty="0"/>
           </a:p>
         </p:txBody>
@@ -1123,10 +876,6 @@
           <a:bodyPr/>
           <a:lstStyle/>
           <a:p>
-            <a:r>
-              <a:rPr lang="en-US" dirty="0"/>
-              <a:t/>
-            </a:r>
             <a:endParaRPr lang="en-US" dirty="0"/>
           </a:p>
         </p:txBody>
@@ -1200,6 +949,11 @@
 <file path=ppt/slideMasters/slideMaster1.xml><?xml version="1.0" encoding="utf-8"?>
 <p:sldMaster xmlns:a="http://schemas.openxmlformats.org/drawingml/2006/main" xmlns:r="http://schemas.openxmlformats.org/officeDocument/2006/relationships" xmlns:p="http://schemas.openxmlformats.org/presentationml/2006/main">
   <p:cSld>
+    <p:bg>
+      <p:bgRef idx="1001">
+        <a:schemeClr val="bg1"/>
+      </p:bgRef>
+    </p:bg>
     <p:spTree>
       <p:nvGrpSpPr>
         <p:cNvPr id="1" name=""/>
@@ -1482,6 +1236,7 @@
         <a:solidFill>
           <a:srgbClr val="1E2761"/>
         </a:solidFill>
+        <a:effectLst/>
       </p:bgPr>
     </p:bg>
     <p:spTree>
@@ -1519,7 +1274,7 @@
           <a:bodyPr wrap="square" rtlCol="0" anchor="ctr"/>
           <a:lstStyle/>
           <a:p>
-            <a:pPr indent="0" marL="0">
+            <a:pPr marL="0" indent="0">
               <a:buNone/>
             </a:pPr>
             <a:r>
@@ -1558,7 +1313,7 @@
           <a:bodyPr wrap="square" rtlCol="0" anchor="ctr"/>
           <a:lstStyle/>
           <a:p>
-            <a:pPr indent="0" marL="0">
+            <a:pPr marL="0" indent="0">
               <a:buNone/>
             </a:pPr>
             <a:r>
@@ -1597,7 +1352,7 @@
           <a:bodyPr wrap="square" rtlCol="0" anchor="ctr"/>
           <a:lstStyle/>
           <a:p>
-            <a:pPr indent="0" marL="0">
+            <a:pPr marL="0" indent="0">
               <a:buNone/>
             </a:pPr>
             <a:r>
@@ -1636,7 +1391,7 @@
           <a:bodyPr wrap="square" rtlCol="0" anchor="ctr"/>
           <a:lstStyle/>
           <a:p>
-            <a:pPr indent="0" marL="0">
+            <a:pPr marL="0" indent="0">
               <a:buNone/>
             </a:pPr>
             <a:r>
@@ -1670,6 +1425,7 @@
         <a:solidFill>
           <a:srgbClr val="FFFFFF"/>
         </a:solidFill>
+        <a:effectLst/>
       </p:bgPr>
     </p:bg>
     <p:spTree>
@@ -1707,7 +1463,7 @@
           <a:bodyPr wrap="square" rtlCol="0" anchor="ctr"/>
           <a:lstStyle/>
           <a:p>
-            <a:pPr indent="0" marL="0">
+            <a:pPr marL="0" indent="0">
               <a:buNone/>
             </a:pPr>
             <a:r>
@@ -1768,7 +1524,7 @@
           <a:bodyPr wrap="square" rtlCol="0" anchor="ctr"/>
           <a:lstStyle/>
           <a:p>
-            <a:pPr indent="0" marL="0">
+            <a:pPr marL="0" indent="0">
               <a:buNone/>
             </a:pPr>
             <a:r>
@@ -1807,7 +1563,7 @@
           <a:bodyPr wrap="square" rtlCol="0" anchor="ctr"/>
           <a:lstStyle/>
           <a:p>
-            <a:pPr indent="0" marL="0">
+            <a:pPr marL="0" indent="0">
               <a:buNone/>
             </a:pPr>
             <a:r>
@@ -1868,7 +1624,7 @@
           <a:bodyPr wrap="square" rtlCol="0" anchor="ctr"/>
           <a:lstStyle/>
           <a:p>
-            <a:pPr indent="0" marL="0">
+            <a:pPr marL="0" indent="0">
               <a:buNone/>
             </a:pPr>
             <a:r>
@@ -1907,7 +1663,7 @@
           <a:bodyPr wrap="square" rtlCol="0" anchor="ctr"/>
           <a:lstStyle/>
           <a:p>
-            <a:pPr indent="0" marL="0">
+            <a:pPr marL="0" indent="0">
               <a:buNone/>
             </a:pPr>
             <a:r>
@@ -1968,7 +1724,7 @@
           <a:bodyPr wrap="square" rtlCol="0" anchor="ctr"/>
           <a:lstStyle/>
           <a:p>
-            <a:pPr indent="0" marL="0">
+            <a:pPr marL="0" indent="0">
               <a:buNone/>
             </a:pPr>
             <a:r>
@@ -2007,7 +1763,7 @@
           <a:bodyPr wrap="square" rtlCol="0" anchor="ctr"/>
           <a:lstStyle/>
           <a:p>
-            <a:pPr indent="0" marL="0">
+            <a:pPr marL="0" indent="0">
               <a:buNone/>
             </a:pPr>
             <a:r>
@@ -2046,7 +1802,7 @@
           <a:bodyPr wrap="square" rtlCol="0" anchor="ctr"/>
           <a:lstStyle/>
           <a:p>
-            <a:pPr indent="0" marL="0">
+            <a:pPr marL="0" indent="0">
               <a:buNone/>
             </a:pPr>
             <a:r>
@@ -2080,6 +1836,7 @@
         <a:solidFill>
           <a:srgbClr val="FFFFFF"/>
         </a:solidFill>
+        <a:effectLst/>
       </p:bgPr>
     </p:bg>
     <p:spTree>
@@ -2117,7 +1874,7 @@
           <a:bodyPr wrap="square" rtlCol="0" anchor="ctr"/>
           <a:lstStyle/>
           <a:p>
-            <a:pPr indent="0" marL="0">
+            <a:pPr marL="0" indent="0">
               <a:buNone/>
             </a:pPr>
             <a:r>
@@ -2176,7 +1933,7 @@
           <a:bodyPr wrap="square" rtlCol="0" anchor="ctr"/>
           <a:lstStyle/>
           <a:p>
-            <a:pPr algn="ctr" indent="0" marL="0">
+            <a:pPr marL="0" indent="0" algn="ctr">
               <a:buNone/>
             </a:pPr>
             <a:r>
@@ -2215,7 +1972,7 @@
           <a:bodyPr wrap="square" rtlCol="0" anchor="ctr"/>
           <a:lstStyle/>
           <a:p>
-            <a:pPr algn="ctr" indent="0" marL="0">
+            <a:pPr marL="0" indent="0" algn="ctr">
               <a:buNone/>
             </a:pPr>
             <a:r>
@@ -2297,7 +2054,7 @@
           <a:bodyPr wrap="square" rtlCol="0" anchor="ctr"/>
           <a:lstStyle/>
           <a:p>
-            <a:pPr algn="ctr" indent="0" marL="0">
+            <a:pPr marL="0" indent="0" algn="ctr">
               <a:buNone/>
             </a:pPr>
             <a:r>
@@ -2336,7 +2093,7 @@
           <a:bodyPr wrap="square" rtlCol="0" anchor="ctr"/>
           <a:lstStyle/>
           <a:p>
-            <a:pPr algn="ctr" indent="0" marL="0">
+            <a:pPr marL="0" indent="0" algn="ctr">
               <a:buNone/>
             </a:pPr>
             <a:r>
@@ -2418,7 +2175,7 @@
           <a:bodyPr wrap="square" rtlCol="0" anchor="ctr"/>
           <a:lstStyle/>
           <a:p>
-            <a:pPr algn="ctr" indent="0" marL="0">
+            <a:pPr marL="0" indent="0" algn="ctr">
               <a:buNone/>
             </a:pPr>
             <a:r>
@@ -2457,7 +2214,7 @@
           <a:bodyPr wrap="square" rtlCol="0" anchor="ctr"/>
           <a:lstStyle/>
           <a:p>
-            <a:pPr algn="ctr" indent="0" marL="0">
+            <a:pPr marL="0" indent="0" algn="ctr">
               <a:buNone/>
             </a:pPr>
             <a:r>
@@ -2539,7 +2296,7 @@
           <a:bodyPr wrap="square" rtlCol="0" anchor="ctr"/>
           <a:lstStyle/>
           <a:p>
-            <a:pPr algn="ctr" indent="0" marL="0">
+            <a:pPr marL="0" indent="0" algn="ctr">
               <a:buNone/>
             </a:pPr>
             <a:r>
@@ -2578,7 +2335,7 @@
           <a:bodyPr wrap="square" rtlCol="0" anchor="ctr"/>
           <a:lstStyle/>
           <a:p>
-            <a:pPr algn="ctr" indent="0" marL="0">
+            <a:pPr marL="0" indent="0" algn="ctr">
               <a:buNone/>
             </a:pPr>
             <a:r>
@@ -2660,7 +2417,7 @@
           <a:bodyPr wrap="square" rtlCol="0" anchor="ctr"/>
           <a:lstStyle/>
           <a:p>
-            <a:pPr algn="ctr" indent="0" marL="0">
+            <a:pPr marL="0" indent="0" algn="ctr">
               <a:buNone/>
             </a:pPr>
             <a:r>
@@ -2699,7 +2456,7 @@
           <a:bodyPr wrap="square" rtlCol="0" anchor="ctr"/>
           <a:lstStyle/>
           <a:p>
-            <a:pPr algn="ctr" indent="0" marL="0">
+            <a:pPr marL="0" indent="0" algn="ctr">
               <a:buNone/>
             </a:pPr>
             <a:r>
@@ -2738,7 +2495,7 @@
           <a:bodyPr wrap="square" rtlCol="0" anchor="ctr"/>
           <a:lstStyle/>
           <a:p>
-            <a:pPr indent="0" marL="0">
+            <a:pPr marL="0" indent="0">
               <a:buNone/>
             </a:pPr>
             <a:r>
@@ -2772,6 +2529,7 @@
         <a:solidFill>
           <a:srgbClr val="1E2761"/>
         </a:solidFill>
+        <a:effectLst/>
       </p:bgPr>
     </p:bg>
     <p:spTree>
@@ -2809,7 +2567,7 @@
           <a:bodyPr wrap="square" rtlCol="0" anchor="ctr"/>
           <a:lstStyle/>
           <a:p>
-            <a:pPr indent="0" marL="0">
+            <a:pPr marL="0" indent="0">
               <a:buNone/>
             </a:pPr>
             <a:r>
@@ -2848,7 +2606,7 @@
           <a:bodyPr wrap="square" rtlCol="0" anchor="ctr"/>
           <a:lstStyle/>
           <a:p>
-            <a:pPr indent="0" marL="0">
+            <a:pPr marL="0" indent="0">
               <a:buNone/>
             </a:pPr>
             <a:r>
@@ -2909,7 +2667,7 @@
           <a:bodyPr wrap="square" rtlCol="0" anchor="ctr"/>
           <a:lstStyle/>
           <a:p>
-            <a:pPr algn="ctr" indent="0" marL="0">
+            <a:pPr marL="0" indent="0" algn="ctr">
               <a:buNone/>
             </a:pPr>
             <a:r>
@@ -2948,7 +2706,7 @@
           <a:bodyPr wrap="square" rtlCol="0" anchor="ctr"/>
           <a:lstStyle/>
           <a:p>
-            <a:pPr algn="ctr" indent="0" marL="0">
+            <a:pPr marL="0" indent="0" algn="ctr">
               <a:buNone/>
             </a:pPr>
             <a:r>
@@ -2965,7 +2723,7 @@
             <a:endParaRPr lang="en-US" sz="1300" dirty="0"/>
           </a:p>
           <a:p>
-            <a:pPr algn="ctr" indent="0" marL="0">
+            <a:pPr marL="0" indent="0" algn="ctr">
               <a:buNone/>
             </a:pPr>
             <a:r>
@@ -3004,7 +2762,7 @@
           <a:bodyPr wrap="square" rtlCol="0" anchor="ctr"/>
           <a:lstStyle/>
           <a:p>
-            <a:pPr algn="ctr" indent="0" marL="0">
+            <a:pPr marL="0" indent="0" algn="ctr">
               <a:buNone/>
             </a:pPr>
             <a:r>
@@ -3065,7 +2823,7 @@
           <a:bodyPr wrap="square" rtlCol="0" anchor="ctr"/>
           <a:lstStyle/>
           <a:p>
-            <a:pPr algn="ctr" indent="0" marL="0">
+            <a:pPr marL="0" indent="0" algn="ctr">
               <a:buNone/>
             </a:pPr>
             <a:r>
@@ -3104,7 +2862,7 @@
           <a:bodyPr wrap="square" rtlCol="0" anchor="ctr"/>
           <a:lstStyle/>
           <a:p>
-            <a:pPr algn="ctr" indent="0" marL="0">
+            <a:pPr marL="0" indent="0" algn="ctr">
               <a:buNone/>
             </a:pPr>
             <a:r>
@@ -3121,7 +2879,7 @@
             <a:endParaRPr lang="en-US" sz="1300" dirty="0"/>
           </a:p>
           <a:p>
-            <a:pPr algn="ctr" indent="0" marL="0">
+            <a:pPr marL="0" indent="0" algn="ctr">
               <a:buNone/>
             </a:pPr>
             <a:r>
@@ -3160,7 +2918,7 @@
           <a:bodyPr wrap="square" rtlCol="0" anchor="ctr"/>
           <a:lstStyle/>
           <a:p>
-            <a:pPr algn="ctr" indent="0" marL="0">
+            <a:pPr marL="0" indent="0" algn="ctr">
               <a:buNone/>
             </a:pPr>
             <a:r>
@@ -3221,7 +2979,7 @@
           <a:bodyPr wrap="square" rtlCol="0" anchor="ctr"/>
           <a:lstStyle/>
           <a:p>
-            <a:pPr algn="ctr" indent="0" marL="0">
+            <a:pPr marL="0" indent="0" algn="ctr">
               <a:buNone/>
             </a:pPr>
             <a:r>
@@ -3260,7 +3018,7 @@
           <a:bodyPr wrap="square" rtlCol="0" anchor="ctr"/>
           <a:lstStyle/>
           <a:p>
-            <a:pPr algn="ctr" indent="0" marL="0">
+            <a:pPr marL="0" indent="0" algn="ctr">
               <a:buNone/>
             </a:pPr>
             <a:r>
@@ -3277,7 +3035,7 @@
             <a:endParaRPr lang="en-US" sz="1300" dirty="0"/>
           </a:p>
           <a:p>
-            <a:pPr algn="ctr" indent="0" marL="0">
+            <a:pPr marL="0" indent="0" algn="ctr">
               <a:buNone/>
             </a:pPr>
             <a:r>
@@ -3316,7 +3074,7 @@
           <a:bodyPr wrap="square" rtlCol="0" anchor="ctr"/>
           <a:lstStyle/>
           <a:p>
-            <a:pPr algn="ctr" indent="0" marL="0">
+            <a:pPr marL="0" indent="0" algn="ctr">
               <a:buNone/>
             </a:pPr>
             <a:r>
@@ -3355,7 +3113,7 @@
           <a:bodyPr wrap="square" rtlCol="0" anchor="ctr"/>
           <a:lstStyle/>
           <a:p>
-            <a:pPr indent="0" marL="0">
+            <a:pPr marL="0" indent="0">
               <a:buNone/>
             </a:pPr>
             <a:r>
@@ -3389,6 +3147,7 @@
         <a:solidFill>
           <a:srgbClr val="FFFFFF"/>
         </a:solidFill>
+        <a:effectLst/>
       </p:bgPr>
     </p:bg>
     <p:spTree>
@@ -3426,7 +3185,7 @@
           <a:bodyPr wrap="square" rtlCol="0" anchor="ctr"/>
           <a:lstStyle/>
           <a:p>
-            <a:pPr indent="0" marL="0">
+            <a:pPr marL="0" indent="0">
               <a:buNone/>
             </a:pPr>
             <a:r>
@@ -3512,7 +3271,7 @@
           <a:bodyPr wrap="square" rtlCol="0" anchor="ctr"/>
           <a:lstStyle/>
           <a:p>
-            <a:pPr indent="0" marL="0">
+            <a:pPr marL="0" indent="0">
               <a:buNone/>
             </a:pPr>
             <a:r>
@@ -3551,7 +3310,7 @@
           <a:bodyPr wrap="square" rtlCol="0" anchor="ctr"/>
           <a:lstStyle/>
           <a:p>
-            <a:pPr indent="0" marL="0">
+            <a:pPr marL="0" indent="0">
               <a:buNone/>
             </a:pPr>
             <a:r>
@@ -3637,7 +3396,7 @@
           <a:bodyPr wrap="square" rtlCol="0" anchor="ctr"/>
           <a:lstStyle/>
           <a:p>
-            <a:pPr indent="0" marL="0">
+            <a:pPr marL="0" indent="0">
               <a:buNone/>
             </a:pPr>
             <a:r>
@@ -3676,7 +3435,7 @@
           <a:bodyPr wrap="square" rtlCol="0" anchor="ctr"/>
           <a:lstStyle/>
           <a:p>
-            <a:pPr indent="0" marL="0">
+            <a:pPr marL="0" indent="0">
               <a:buNone/>
             </a:pPr>
             <a:r>
@@ -3762,7 +3521,7 @@
           <a:bodyPr wrap="square" rtlCol="0" anchor="ctr"/>
           <a:lstStyle/>
           <a:p>
-            <a:pPr indent="0" marL="0">
+            <a:pPr marL="0" indent="0">
               <a:buNone/>
             </a:pPr>
             <a:r>
@@ -3801,7 +3560,7 @@
           <a:bodyPr wrap="square" rtlCol="0" anchor="ctr"/>
           <a:lstStyle/>
           <a:p>
-            <a:pPr indent="0" marL="0">
+            <a:pPr marL="0" indent="0">
               <a:buNone/>
             </a:pPr>
             <a:r>
@@ -3887,7 +3646,7 @@
           <a:bodyPr wrap="square" rtlCol="0" anchor="ctr"/>
           <a:lstStyle/>
           <a:p>
-            <a:pPr indent="0" marL="0">
+            <a:pPr marL="0" indent="0">
               <a:buNone/>
             </a:pPr>
             <a:r>
@@ -3926,7 +3685,7 @@
           <a:bodyPr wrap="square" rtlCol="0" anchor="ctr"/>
           <a:lstStyle/>
           <a:p>
-            <a:pPr indent="0" marL="0">
+            <a:pPr marL="0" indent="0">
               <a:buNone/>
             </a:pPr>
             <a:r>
@@ -3965,7 +3724,7 @@
           <a:bodyPr wrap="square" rtlCol="0" anchor="ctr"/>
           <a:lstStyle/>
           <a:p>
-            <a:pPr indent="0" marL="0">
+            <a:pPr marL="0" indent="0">
               <a:buNone/>
             </a:pPr>
             <a:r>
@@ -3999,6 +3758,7 @@
         <a:solidFill>
           <a:srgbClr val="FFFFFF"/>
         </a:solidFill>
+        <a:effectLst/>
       </p:bgPr>
     </p:bg>
     <p:spTree>
@@ -4036,7 +3796,7 @@
           <a:bodyPr wrap="square" rtlCol="0" anchor="ctr"/>
           <a:lstStyle/>
           <a:p>
-            <a:pPr indent="0" marL="0">
+            <a:pPr marL="0" indent="0">
               <a:buNone/>
             </a:pPr>
             <a:r>
@@ -4095,7 +3855,7 @@
           <a:bodyPr wrap="square" rtlCol="0" anchor="ctr"/>
           <a:lstStyle/>
           <a:p>
-            <a:pPr indent="0" marL="0">
+            <a:pPr marL="0" indent="0">
               <a:buNone/>
             </a:pPr>
             <a:r>
@@ -4134,7 +3894,7 @@
           <a:bodyPr wrap="square" rtlCol="0" anchor="ctr"/>
           <a:lstStyle/>
           <a:p>
-            <a:pPr indent="0" marL="0">
+            <a:pPr marL="0" indent="0">
               <a:buNone/>
             </a:pPr>
             <a:r>
@@ -4193,7 +3953,7 @@
           <a:bodyPr wrap="square" rtlCol="0" anchor="ctr"/>
           <a:lstStyle/>
           <a:p>
-            <a:pPr indent="0" marL="0">
+            <a:pPr marL="0" indent="0">
               <a:buNone/>
             </a:pPr>
             <a:r>
@@ -4232,7 +3992,7 @@
           <a:bodyPr wrap="square" rtlCol="0" anchor="ctr"/>
           <a:lstStyle/>
           <a:p>
-            <a:pPr indent="0" marL="0">
+            <a:pPr marL="0" indent="0">
               <a:buNone/>
             </a:pPr>
             <a:r>
@@ -4291,7 +4051,7 @@
           <a:bodyPr wrap="square" rtlCol="0" anchor="ctr"/>
           <a:lstStyle/>
           <a:p>
-            <a:pPr indent="0" marL="0">
+            <a:pPr marL="0" indent="0">
               <a:buNone/>
             </a:pPr>
             <a:r>
@@ -4330,7 +4090,7 @@
           <a:bodyPr wrap="square" rtlCol="0" anchor="ctr"/>
           <a:lstStyle/>
           <a:p>
-            <a:pPr indent="0" marL="0">
+            <a:pPr marL="0" indent="0">
               <a:buNone/>
             </a:pPr>
             <a:r>
@@ -4369,7 +4129,7 @@
           <a:bodyPr wrap="square" rtlCol="0" anchor="ctr"/>
           <a:lstStyle/>
           <a:p>
-            <a:pPr indent="0" marL="0">
+            <a:pPr marL="0" indent="0">
               <a:buNone/>
             </a:pPr>
             <a:r>
@@ -4381,7 +4141,48 @@
                 <a:ea typeface="Calibri" pitchFamily="34" charset="-122"/>
                 <a:cs typeface="Calibri" pitchFamily="34" charset="-120"/>
               </a:rPr>
-              <a:t>Dashboard URL: [add after deployment]        Scoring Service URL: [add after deployment]</a:t>
+              <a:t>Dashboard URL: </a:t>
+            </a:r>
+            <a:r>
+              <a:rPr lang="en-US" sz="1400" dirty="0">
+                <a:hlinkClick r:id="rId3"/>
+              </a:rPr>
+              <a:t>Project FORESIGHT — </a:t>
+            </a:r>
+            <a:r>
+              <a:rPr lang="en-US" sz="1400" dirty="0" err="1">
+                <a:hlinkClick r:id="rId3"/>
+              </a:rPr>
+              <a:t>NorthBay</a:t>
+            </a:r>
+            <a:r>
+              <a:rPr lang="en-US" sz="1400" dirty="0">
+                <a:hlinkClick r:id="rId3"/>
+              </a:rPr>
+              <a:t> Living · </a:t>
+            </a:r>
+            <a:r>
+              <a:rPr lang="en-US" sz="1400" dirty="0" err="1">
+                <a:hlinkClick r:id="rId3"/>
+              </a:rPr>
+              <a:t>Streamlit</a:t>
+            </a:r>
+            <a:r>
+              <a:rPr lang="en-US" sz="1300" b="1" dirty="0">
+                <a:solidFill>
+                  <a:srgbClr val="1E2761"/>
+                </a:solidFill>
+                <a:latin typeface="Calibri" pitchFamily="34" charset="0"/>
+                <a:ea typeface="Calibri" pitchFamily="34" charset="-122"/>
+                <a:cs typeface="Calibri" pitchFamily="34" charset="-120"/>
+              </a:rPr>
+              <a:t>       Scoring Service URL: </a:t>
+            </a:r>
+            <a:r>
+              <a:rPr lang="en-US" sz="1400" dirty="0">
+                <a:hlinkClick r:id="rId4"/>
+              </a:rPr>
+              <a:t>Project FORESIGHT Scoring Service - Swagger UI</a:t>
             </a:r>
             <a:endParaRPr lang="en-US" sz="1300" dirty="0"/>
           </a:p>
@@ -4403,6 +4204,7 @@
         <a:solidFill>
           <a:srgbClr val="1E2761"/>
         </a:solidFill>
+        <a:effectLst/>
       </p:bgPr>
     </p:bg>
     <p:spTree>
@@ -4440,7 +4242,7 @@
           <a:bodyPr wrap="square" rtlCol="0" anchor="ctr"/>
           <a:lstStyle/>
           <a:p>
-            <a:pPr indent="0" marL="0">
+            <a:pPr marL="0" indent="0">
               <a:buNone/>
             </a:pPr>
             <a:r>
@@ -4479,7 +4281,7 @@
           <a:bodyPr wrap="square" rtlCol="0" anchor="ctr"/>
           <a:lstStyle/>
           <a:p>
-            <a:pPr indent="0" marL="0">
+            <a:pPr marL="0" indent="0">
               <a:buNone/>
             </a:pPr>
             <a:r>
@@ -4518,7 +4320,7 @@
           <a:bodyPr wrap="square" rtlCol="0" anchor="ctr"/>
           <a:lstStyle/>
           <a:p>
-            <a:pPr indent="0" marL="0">
+            <a:pPr marL="0" indent="0">
               <a:lnSpc>
                 <a:spcPct val="160000"/>
               </a:lnSpc>
@@ -4535,12 +4337,6 @@
               </a:rPr>
               <a:t>1. </a:t>
             </a:r>
-            <a:pPr indent="0" marL="0">
-              <a:lnSpc>
-                <a:spcPct val="160000"/>
-              </a:lnSpc>
-              <a:buNone/>
-            </a:pPr>
             <a:r>
               <a:rPr lang="en-US" sz="1600" dirty="0">
                 <a:solidFill>
@@ -4553,12 +4349,6 @@
               <a:t>Markdown / clear (19 series): FOODS_1_004 is overstocked across nearly every store — CA_1, WI_1, WI_3, CA_3, TX_2 and more. This looks like a single product issue, not random noise — worth a manual pricing/promo review.
 </a:t>
             </a:r>
-            <a:pPr indent="0" marL="0">
-              <a:lnSpc>
-                <a:spcPct val="160000"/>
-              </a:lnSpc>
-              <a:buNone/>
-            </a:pPr>
             <a:r>
               <a:rPr lang="en-US" sz="1600" b="1" dirty="0">
                 <a:solidFill>
@@ -4570,12 +4360,6 @@
               </a:rPr>
               <a:t>2. </a:t>
             </a:r>
-            <a:pPr indent="0" marL="0">
-              <a:lnSpc>
-                <a:spcPct val="160000"/>
-              </a:lnSpc>
-              <a:buNone/>
-            </a:pPr>
             <a:r>
               <a:rPr lang="en-US" sz="1600" dirty="0">
                 <a:solidFill>
@@ -4588,12 +4372,6 @@
               <a:t>Reorder now: none flagged in this run.
 </a:t>
             </a:r>
-            <a:pPr indent="0" marL="0">
-              <a:lnSpc>
-                <a:spcPct val="160000"/>
-              </a:lnSpc>
-              <a:buNone/>
-            </a:pPr>
             <a:r>
               <a:rPr lang="en-US" sz="1600" b="1" dirty="0">
                 <a:solidFill>
@@ -4605,12 +4383,6 @@
               </a:rPr>
               <a:t>3. </a:t>
             </a:r>
-            <a:pPr indent="0" marL="0">
-              <a:lnSpc>
-                <a:spcPct val="160000"/>
-              </a:lnSpc>
-              <a:buNone/>
-            </a:pPr>
             <a:r>
               <a:rPr lang="en-US" sz="1600" dirty="0">
                 <a:solidFill>
@@ -4648,7 +4420,7 @@
           <a:bodyPr wrap="square" rtlCol="0" anchor="ctr"/>
           <a:lstStyle/>
           <a:p>
-            <a:pPr indent="0" marL="0">
+            <a:pPr marL="0" indent="0">
               <a:buNone/>
             </a:pPr>
             <a:r>
@@ -4682,6 +4454,7 @@
         <a:solidFill>
           <a:srgbClr val="FFFFFF"/>
         </a:solidFill>
+        <a:effectLst/>
       </p:bgPr>
     </p:bg>
     <p:spTree>
@@ -4719,7 +4492,7 @@
           <a:bodyPr wrap="square" rtlCol="0" anchor="ctr"/>
           <a:lstStyle/>
           <a:p>
-            <a:pPr indent="0" marL="0">
+            <a:pPr marL="0" indent="0">
               <a:buNone/>
             </a:pPr>
             <a:r>
@@ -4758,7 +4531,7 @@
           <a:bodyPr wrap="square" rtlCol="0" anchor="ctr"/>
           <a:lstStyle/>
           <a:p>
-            <a:pPr indent="0" marL="0">
+            <a:pPr marL="0" indent="0">
               <a:buNone/>
             </a:pPr>
             <a:r>
@@ -4797,7 +4570,7 @@
           <a:bodyPr wrap="square" rtlCol="0" anchor="ctr"/>
           <a:lstStyle/>
           <a:p>
-            <a:pPr indent="0" marL="0">
+            <a:pPr marL="0" indent="0">
               <a:lnSpc>
                 <a:spcPct val="140000"/>
               </a:lnSpc>
@@ -4813,9 +4586,75 @@
                 <a:cs typeface="Calibri" pitchFamily="34" charset="-120"/>
               </a:rPr>
               <a:t>• Inventory position and unit cost are simulated, not live client data
+• Forecast accuracy is honestly reported, including where the model degrades on unseen data
+• Sparse-history SKUs fall back to category-level patterns
 </a:t>
             </a:r>
-            <a:pPr indent="0" marL="0">
+            <a:endParaRPr lang="en-US" sz="1300" dirty="0"/>
+          </a:p>
+        </p:txBody>
+      </p:sp>
+      <p:sp>
+        <p:nvSpPr>
+          <p:cNvPr id="5" name="Text 3"/>
+          <p:cNvSpPr/>
+          <p:nvPr/>
+        </p:nvSpPr>
+        <p:spPr>
+          <a:xfrm>
+            <a:off x="6309360" y="1371600"/>
+            <a:ext cx="5303520" cy="457200"/>
+          </a:xfrm>
+          <a:prstGeom prst="rect">
+            <a:avLst/>
+          </a:prstGeom>
+          <a:noFill/>
+          <a:ln/>
+        </p:spPr>
+        <p:txBody>
+          <a:bodyPr wrap="square" rtlCol="0" anchor="ctr"/>
+          <a:lstStyle/>
+          <a:p>
+            <a:pPr marL="0" indent="0">
+              <a:buNone/>
+            </a:pPr>
+            <a:r>
+              <a:rPr lang="en-US" sz="1800" b="1" dirty="0">
+                <a:solidFill>
+                  <a:srgbClr val="1E2761"/>
+                </a:solidFill>
+                <a:latin typeface="Calibri" pitchFamily="34" charset="0"/>
+                <a:ea typeface="Calibri" pitchFamily="34" charset="-122"/>
+                <a:cs typeface="Calibri" pitchFamily="34" charset="-120"/>
+              </a:rPr>
+              <a:t>What's next</a:t>
+            </a:r>
+            <a:endParaRPr lang="en-US" sz="1800" dirty="0"/>
+          </a:p>
+        </p:txBody>
+      </p:sp>
+      <p:sp>
+        <p:nvSpPr>
+          <p:cNvPr id="6" name="Text 4"/>
+          <p:cNvSpPr/>
+          <p:nvPr/>
+        </p:nvSpPr>
+        <p:spPr>
+          <a:xfrm>
+            <a:off x="6309360" y="1920240"/>
+            <a:ext cx="5303520" cy="2286000"/>
+          </a:xfrm>
+          <a:prstGeom prst="rect">
+            <a:avLst/>
+          </a:prstGeom>
+          <a:noFill/>
+          <a:ln/>
+        </p:spPr>
+        <p:txBody>
+          <a:bodyPr wrap="square" rtlCol="0" anchor="ctr"/>
+          <a:lstStyle/>
+          <a:p>
+            <a:pPr marL="0" indent="0">
               <a:lnSpc>
                 <a:spcPct val="140000"/>
               </a:lnSpc>
@@ -4830,143 +4669,9 @@
                 <a:ea typeface="Calibri" pitchFamily="34" charset="-122"/>
                 <a:cs typeface="Calibri" pitchFamily="34" charset="-120"/>
               </a:rPr>
-              <a:t>• Forecast accuracy is honestly reported, including where the model degrades on unseen data
-</a:t>
-            </a:r>
-            <a:pPr indent="0" marL="0">
-              <a:lnSpc>
-                <a:spcPct val="140000"/>
-              </a:lnSpc>
-              <a:buNone/>
-            </a:pPr>
-            <a:r>
-              <a:rPr lang="en-US" sz="1300" dirty="0">
-                <a:solidFill>
-                  <a:srgbClr val="6B7A99"/>
-                </a:solidFill>
-                <a:latin typeface="Calibri" pitchFamily="34" charset="0"/>
-                <a:ea typeface="Calibri" pitchFamily="34" charset="-122"/>
-                <a:cs typeface="Calibri" pitchFamily="34" charset="-120"/>
-              </a:rPr>
-              <a:t>• Sparse-history SKUs fall back to category-level patterns
-</a:t>
-            </a:r>
-            <a:endParaRPr lang="en-US" sz="1300" dirty="0"/>
-          </a:p>
-        </p:txBody>
-      </p:sp>
-      <p:sp>
-        <p:nvSpPr>
-          <p:cNvPr id="5" name="Text 3"/>
-          <p:cNvSpPr/>
-          <p:nvPr/>
-        </p:nvSpPr>
-        <p:spPr>
-          <a:xfrm>
-            <a:off x="6309360" y="1371600"/>
-            <a:ext cx="5303520" cy="457200"/>
-          </a:xfrm>
-          <a:prstGeom prst="rect">
-            <a:avLst/>
-          </a:prstGeom>
-          <a:noFill/>
-          <a:ln/>
-        </p:spPr>
-        <p:txBody>
-          <a:bodyPr wrap="square" rtlCol="0" anchor="ctr"/>
-          <a:lstStyle/>
-          <a:p>
-            <a:pPr indent="0" marL="0">
-              <a:buNone/>
-            </a:pPr>
-            <a:r>
-              <a:rPr lang="en-US" sz="1800" b="1" dirty="0">
-                <a:solidFill>
-                  <a:srgbClr val="1E2761"/>
-                </a:solidFill>
-                <a:latin typeface="Calibri" pitchFamily="34" charset="0"/>
-                <a:ea typeface="Calibri" pitchFamily="34" charset="-122"/>
-                <a:cs typeface="Calibri" pitchFamily="34" charset="-120"/>
-              </a:rPr>
-              <a:t>What's next</a:t>
-            </a:r>
-            <a:endParaRPr lang="en-US" sz="1800" dirty="0"/>
-          </a:p>
-        </p:txBody>
-      </p:sp>
-      <p:sp>
-        <p:nvSpPr>
-          <p:cNvPr id="6" name="Text 4"/>
-          <p:cNvSpPr/>
-          <p:nvPr/>
-        </p:nvSpPr>
-        <p:spPr>
-          <a:xfrm>
-            <a:off x="6309360" y="1920240"/>
-            <a:ext cx="5303520" cy="2286000"/>
-          </a:xfrm>
-          <a:prstGeom prst="rect">
-            <a:avLst/>
-          </a:prstGeom>
-          <a:noFill/>
-          <a:ln/>
-        </p:spPr>
-        <p:txBody>
-          <a:bodyPr wrap="square" rtlCol="0" anchor="ctr"/>
-          <a:lstStyle/>
-          <a:p>
-            <a:pPr indent="0" marL="0">
-              <a:lnSpc>
-                <a:spcPct val="140000"/>
-              </a:lnSpc>
-              <a:buNone/>
-            </a:pPr>
-            <a:r>
-              <a:rPr lang="en-US" sz="1300" dirty="0">
-                <a:solidFill>
-                  <a:srgbClr val="6B7A99"/>
-                </a:solidFill>
-                <a:latin typeface="Calibri" pitchFamily="34" charset="0"/>
-                <a:ea typeface="Calibri" pitchFamily="34" charset="-122"/>
-                <a:cs typeface="Calibri" pitchFamily="34" charset="-120"/>
-              </a:rPr>
               <a:t>• Connect to live sales and inventory feeds
-</a:t>
-            </a:r>
-            <a:pPr indent="0" marL="0">
-              <a:lnSpc>
-                <a:spcPct val="140000"/>
-              </a:lnSpc>
-              <a:buNone/>
-            </a:pPr>
-            <a:r>
-              <a:rPr lang="en-US" sz="1300" dirty="0">
-                <a:solidFill>
-                  <a:srgbClr val="6B7A99"/>
-                </a:solidFill>
-                <a:latin typeface="Calibri" pitchFamily="34" charset="0"/>
-                <a:ea typeface="Calibri" pitchFamily="34" charset="-122"/>
-                <a:cs typeface="Calibri" pitchFamily="34" charset="-120"/>
-              </a:rPr>
-              <a:t>• Monitor forecast drift monthly and retrain as needed
-</a:t>
-            </a:r>
-            <a:pPr indent="0" marL="0">
-              <a:lnSpc>
-                <a:spcPct val="140000"/>
-              </a:lnSpc>
-              <a:buNone/>
-            </a:pPr>
-            <a:r>
-              <a:rPr lang="en-US" sz="1300" dirty="0">
-                <a:solidFill>
-                  <a:srgbClr val="6B7A99"/>
-                </a:solidFill>
-                <a:latin typeface="Calibri" pitchFamily="34" charset="0"/>
-                <a:ea typeface="Calibri" pitchFamily="34" charset="-122"/>
-                <a:cs typeface="Calibri" pitchFamily="34" charset="-120"/>
-              </a:rPr>
-              <a:t>• Extend risk scoring with a what-if control for lead-time changes
+• Monitor forecast drift monthly and retrain as needed
+• Extend risk scoring with a what-if control for lead-time changes
 </a:t>
             </a:r>
             <a:endParaRPr lang="en-US" sz="1300" dirty="0"/>
@@ -4994,7 +4699,7 @@
           <a:bodyPr wrap="square" rtlCol="0" anchor="ctr"/>
           <a:lstStyle/>
           <a:p>
-            <a:pPr indent="0" marL="0">
+            <a:pPr marL="0" indent="0">
               <a:buNone/>
             </a:pPr>
             <a:r>
@@ -5313,4 +5018,299 @@
     </a:ext>
   </a:extLst>
 </a:theme>
+</file>
+
+<file path=ppt/theme/theme2.xml><?xml version="1.0" encoding="utf-8"?>
+<a:theme xmlns:a="http://schemas.openxmlformats.org/drawingml/2006/main" name="Office Theme">
+  <a:themeElements>
+    <a:clrScheme name="Office">
+      <a:dk1>
+        <a:sysClr val="windowText" lastClr="000000"/>
+      </a:dk1>
+      <a:lt1>
+        <a:sysClr val="window" lastClr="FFFFFF"/>
+      </a:lt1>
+      <a:dk2>
+        <a:srgbClr val="44546A"/>
+      </a:dk2>
+      <a:lt2>
+        <a:srgbClr val="E7E6E6"/>
+      </a:lt2>
+      <a:accent1>
+        <a:srgbClr val="4472C4"/>
+      </a:accent1>
+      <a:accent2>
+        <a:srgbClr val="ED7D31"/>
+      </a:accent2>
+      <a:accent3>
+        <a:srgbClr val="A5A5A5"/>
+      </a:accent3>
+      <a:accent4>
+        <a:srgbClr val="FFC000"/>
+      </a:accent4>
+      <a:accent5>
+        <a:srgbClr val="5B9BD5"/>
+      </a:accent5>
+      <a:accent6>
+        <a:srgbClr val="70AD47"/>
+      </a:accent6>
+      <a:hlink>
+        <a:srgbClr val="0563C1"/>
+      </a:hlink>
+      <a:folHlink>
+        <a:srgbClr val="954F72"/>
+      </a:folHlink>
+    </a:clrScheme>
+    <a:fontScheme name="Office">
+      <a:majorFont>
+        <a:latin typeface="Calibri Light" panose="020F0302020204030204"/>
+        <a:ea typeface=""/>
+        <a:cs typeface=""/>
+        <a:font script="Jpan" typeface="游ゴシック Light"/>
+        <a:font script="Hang" typeface="맑은 고딕"/>
+        <a:font script="Hans" typeface="等线 Light"/>
+        <a:font script="Hant" typeface="新細明體"/>
+        <a:font script="Arab" typeface="Times New Roman"/>
+        <a:font script="Hebr" typeface="Times New Roman"/>
+        <a:font script="Thai" typeface="Angsana New"/>
+        <a:font script="Ethi" typeface="Nyala"/>
+        <a:font script="Beng" typeface="Vrinda"/>
+        <a:font script="Gujr" typeface="Shruti"/>
+        <a:font script="Khmr" typeface="MoolBoran"/>
+        <a:font script="Knda" typeface="Tunga"/>
+        <a:font script="Guru" typeface="Raavi"/>
+        <a:font script="Cans" typeface="Euphemia"/>
+        <a:font script="Cher" typeface="Plantagenet Cherokee"/>
+        <a:font script="Yiii" typeface="Microsoft Yi Baiti"/>
+        <a:font script="Tibt" typeface="Microsoft Himalaya"/>
+        <a:font script="Thaa" typeface="MV Boli"/>
+        <a:font script="Deva" typeface="Mangal"/>
+        <a:font script="Telu" typeface="Gautami"/>
+        <a:font script="Taml" typeface="Latha"/>
+        <a:font script="Syrc" typeface="Estrangelo Edessa"/>
+        <a:font script="Orya" typeface="Kalinga"/>
+        <a:font script="Mlym" typeface="Kartika"/>
+        <a:font script="Laoo" typeface="DokChampa"/>
+        <a:font script="Sinh" typeface="Iskoola Pota"/>
+        <a:font script="Mong" typeface="Mongolian Baiti"/>
+        <a:font script="Viet" typeface="Times New Roman"/>
+        <a:font script="Uigh" typeface="Microsoft Uighur"/>
+        <a:font script="Geor" typeface="Sylfaen"/>
+        <a:font script="Armn" typeface="Arial"/>
+        <a:font script="Bugi" typeface="Leelawadee UI"/>
+        <a:font script="Bopo" typeface="Microsoft JhengHei"/>
+        <a:font script="Java" typeface="Javanese Text"/>
+        <a:font script="Lisu" typeface="Segoe UI"/>
+        <a:font script="Mymr" typeface="Myanmar Text"/>
+        <a:font script="Nkoo" typeface="Ebrima"/>
+        <a:font script="Olck" typeface="Nirmala UI"/>
+        <a:font script="Osma" typeface="Ebrima"/>
+        <a:font script="Phag" typeface="Phagspa"/>
+        <a:font script="Syrn" typeface="Estrangelo Edessa"/>
+        <a:font script="Syrj" typeface="Estrangelo Edessa"/>
+        <a:font script="Syre" typeface="Estrangelo Edessa"/>
+        <a:font script="Sora" typeface="Nirmala UI"/>
+        <a:font script="Tale" typeface="Microsoft Tai Le"/>
+        <a:font script="Talu" typeface="Microsoft New Tai Lue"/>
+        <a:font script="Tfng" typeface="Ebrima"/>
+      </a:majorFont>
+      <a:minorFont>
+        <a:latin typeface="Calibri" panose="020F0502020204030204"/>
+        <a:ea typeface=""/>
+        <a:cs typeface=""/>
+        <a:font script="Jpan" typeface="游ゴシック"/>
+        <a:font script="Hang" typeface="맑은 고딕"/>
+        <a:font script="Hans" typeface="等线"/>
+        <a:font script="Hant" typeface="新細明體"/>
+        <a:font script="Arab" typeface="Arial"/>
+        <a:font script="Hebr" typeface="Arial"/>
+        <a:font script="Thai" typeface="Cordia New"/>
+        <a:font script="Ethi" typeface="Nyala"/>
+        <a:font script="Beng" typeface="Vrinda"/>
+        <a:font script="Gujr" typeface="Shruti"/>
+        <a:font script="Khmr" typeface="DaunPenh"/>
+        <a:font script="Knda" typeface="Tunga"/>
+        <a:font script="Guru" typeface="Raavi"/>
+        <a:font script="Cans" typeface="Euphemia"/>
+        <a:font script="Cher" typeface="Plantagenet Cherokee"/>
+        <a:font script="Yiii" typeface="Microsoft Yi Baiti"/>
+        <a:font script="Tibt" typeface="Microsoft Himalaya"/>
+        <a:font script="Thaa" typeface="MV Boli"/>
+        <a:font script="Deva" typeface="Mangal"/>
+        <a:font script="Telu" typeface="Gautami"/>
+        <a:font script="Taml" typeface="Latha"/>
+        <a:font script="Syrc" typeface="Estrangelo Edessa"/>
+        <a:font script="Orya" typeface="Kalinga"/>
+        <a:font script="Mlym" typeface="Kartika"/>
+        <a:font script="Laoo" typeface="DokChampa"/>
+        <a:font script="Sinh" typeface="Iskoola Pota"/>
+        <a:font script="Mong" typeface="Mongolian Baiti"/>
+        <a:font script="Viet" typeface="Arial"/>
+        <a:font script="Uigh" typeface="Microsoft Uighur"/>
+        <a:font script="Geor" typeface="Sylfaen"/>
+        <a:font script="Armn" typeface="Arial"/>
+        <a:font script="Bugi" typeface="Leelawadee UI"/>
+        <a:font script="Bopo" typeface="Microsoft JhengHei"/>
+        <a:font script="Java" typeface="Javanese Text"/>
+        <a:font script="Lisu" typeface="Segoe UI"/>
+        <a:font script="Mymr" typeface="Myanmar Text"/>
+        <a:font script="Nkoo" typeface="Ebrima"/>
+        <a:font script="Olck" typeface="Nirmala UI"/>
+        <a:font script="Osma" typeface="Ebrima"/>
+        <a:font script="Phag" typeface="Phagspa"/>
+        <a:font script="Syrn" typeface="Estrangelo Edessa"/>
+        <a:font script="Syrj" typeface="Estrangelo Edessa"/>
+        <a:font script="Syre" typeface="Estrangelo Edessa"/>
+        <a:font script="Sora" typeface="Nirmala UI"/>
+        <a:font script="Tale" typeface="Microsoft Tai Le"/>
+        <a:font script="Talu" typeface="Microsoft New Tai Lue"/>
+        <a:font script="Tfng" typeface="Ebrima"/>
+      </a:minorFont>
+    </a:fontScheme>
+    <a:fmtScheme name="Office">
+      <a:fillStyleLst>
+        <a:solidFill>
+          <a:schemeClr val="phClr"/>
+        </a:solidFill>
+        <a:gradFill rotWithShape="1">
+          <a:gsLst>
+            <a:gs pos="0">
+              <a:schemeClr val="phClr">
+                <a:lumMod val="110000"/>
+                <a:satMod val="105000"/>
+                <a:tint val="67000"/>
+              </a:schemeClr>
+            </a:gs>
+            <a:gs pos="50000">
+              <a:schemeClr val="phClr">
+                <a:lumMod val="105000"/>
+                <a:satMod val="103000"/>
+                <a:tint val="73000"/>
+              </a:schemeClr>
+            </a:gs>
+            <a:gs pos="100000">
+              <a:schemeClr val="phClr">
+                <a:lumMod val="105000"/>
+                <a:satMod val="109000"/>
+                <a:tint val="81000"/>
+              </a:schemeClr>
+            </a:gs>
+          </a:gsLst>
+          <a:lin ang="5400000" scaled="0"/>
+        </a:gradFill>
+        <a:gradFill rotWithShape="1">
+          <a:gsLst>
+            <a:gs pos="0">
+              <a:schemeClr val="phClr">
+                <a:satMod val="103000"/>
+                <a:lumMod val="102000"/>
+                <a:tint val="94000"/>
+              </a:schemeClr>
+            </a:gs>
+            <a:gs pos="50000">
+              <a:schemeClr val="phClr">
+                <a:satMod val="110000"/>
+                <a:lumMod val="100000"/>
+                <a:shade val="100000"/>
+              </a:schemeClr>
+            </a:gs>
+            <a:gs pos="100000">
+              <a:schemeClr val="phClr">
+                <a:lumMod val="99000"/>
+                <a:satMod val="120000"/>
+                <a:shade val="78000"/>
+              </a:schemeClr>
+            </a:gs>
+          </a:gsLst>
+          <a:lin ang="5400000" scaled="0"/>
+        </a:gradFill>
+      </a:fillStyleLst>
+      <a:lnStyleLst>
+        <a:ln w="6350" cap="flat" cmpd="sng" algn="ctr">
+          <a:solidFill>
+            <a:schemeClr val="phClr"/>
+          </a:solidFill>
+          <a:prstDash val="solid"/>
+          <a:miter lim="800000"/>
+        </a:ln>
+        <a:ln w="12700" cap="flat" cmpd="sng" algn="ctr">
+          <a:solidFill>
+            <a:schemeClr val="phClr"/>
+          </a:solidFill>
+          <a:prstDash val="solid"/>
+          <a:miter lim="800000"/>
+        </a:ln>
+        <a:ln w="19050" cap="flat" cmpd="sng" algn="ctr">
+          <a:solidFill>
+            <a:schemeClr val="phClr"/>
+          </a:solidFill>
+          <a:prstDash val="solid"/>
+          <a:miter lim="800000"/>
+        </a:ln>
+      </a:lnStyleLst>
+      <a:effectStyleLst>
+        <a:effectStyle>
+          <a:effectLst/>
+        </a:effectStyle>
+        <a:effectStyle>
+          <a:effectLst/>
+        </a:effectStyle>
+        <a:effectStyle>
+          <a:effectLst>
+            <a:outerShdw blurRad="57150" dist="19050" dir="5400000" algn="ctr" rotWithShape="0">
+              <a:srgbClr val="000000">
+                <a:alpha val="63000"/>
+              </a:srgbClr>
+            </a:outerShdw>
+          </a:effectLst>
+        </a:effectStyle>
+      </a:effectStyleLst>
+      <a:bgFillStyleLst>
+        <a:solidFill>
+          <a:schemeClr val="phClr"/>
+        </a:solidFill>
+        <a:solidFill>
+          <a:schemeClr val="phClr">
+            <a:tint val="95000"/>
+            <a:satMod val="170000"/>
+          </a:schemeClr>
+        </a:solidFill>
+        <a:gradFill rotWithShape="1">
+          <a:gsLst>
+            <a:gs pos="0">
+              <a:schemeClr val="phClr">
+                <a:tint val="93000"/>
+                <a:satMod val="150000"/>
+                <a:shade val="98000"/>
+                <a:lumMod val="102000"/>
+              </a:schemeClr>
+            </a:gs>
+            <a:gs pos="50000">
+              <a:schemeClr val="phClr">
+                <a:tint val="98000"/>
+                <a:satMod val="130000"/>
+                <a:shade val="90000"/>
+                <a:lumMod val="103000"/>
+              </a:schemeClr>
+            </a:gs>
+            <a:gs pos="100000">
+              <a:schemeClr val="phClr">
+                <a:shade val="63000"/>
+                <a:satMod val="120000"/>
+              </a:schemeClr>
+            </a:gs>
+          </a:gsLst>
+          <a:lin ang="5400000" scaled="0"/>
+        </a:gradFill>
+      </a:bgFillStyleLst>
+    </a:fmtScheme>
+  </a:themeElements>
+  <a:objectDefaults/>
+  <a:extraClrSchemeLst/>
+  <a:extLst>
+    <a:ext uri="{05A4C25C-085E-4340-85A3-A5531E510DB2}">
+      <thm15:themeFamily xmlns:thm15="http://schemas.microsoft.com/office/thememl/2012/main" name="Office Theme" id="{62F939B6-93AF-4DB8-9C6B-D6C7DFDC589F}" vid="{4A3C46E8-61CC-4603-A589-7422A47A8E4A}"/>
+    </a:ext>
+  </a:extLst>
+</a:theme>
 </file>
</xml_diff>